<commit_message>
[DOCS] Correct the schema step of Lab 09
The TYPO3 core has no database:updateschema command, neither on
12.4 nor on 13.4. It is provided by TYPO3 Console, since version 8.0
as "typo3 database:updateschema", before that as "typo3cms". The core
schema step on the command line is extension:setup, which creates
and alters tables and fields but never drops or renames them.

Lab 09 also ran the upgrade wizards before the schema update, against
the order the talk teaches. Run extension:setup first, flush the caches
so the wizard from Lab 07 is registered, then list and run the wizards.

Rewrite the questions and solutions accordingly, fix the duplicated
answer number, and update the slides in docs/, whose "Make it
repeatable" slide had the same order and command.
</commit_message>
<xml_diff>
--- a/docs/fly-the-upgrade-slides.pptx
+++ b/docs/fly-the-upgrade-slides.pptx
@@ -54974,7 +54974,7 @@
         <p:spPr>
           <a:xfrm>
             <a:off x="566928" y="1975104"/>
-            <a:ext cx="38100" cy="2176272"/>
+            <a:ext cx="38100" cy="2020824"/>
           </a:xfrm>
           <a:prstGeom prst="rect">
             <a:avLst/>
@@ -55018,7 +55018,7 @@
         <p:spPr>
           <a:xfrm>
             <a:off x="603504" y="1975104"/>
-            <a:ext cx="11021263" cy="2176272"/>
+            <a:ext cx="11021263" cy="2020824"/>
           </a:xfrm>
           <a:prstGeom prst="rect">
             <a:avLst/>
@@ -55064,7 +55064,7 @@
         <p:spPr>
           <a:xfrm>
             <a:off x="749808" y="2084832"/>
-            <a:ext cx="10728655" cy="1956816"/>
+            <a:ext cx="10728655" cy="1801368"/>
           </a:xfrm>
           <a:prstGeom prst="rect">
             <a:avLst/>
@@ -55089,7 +55089,7 @@
                 </a:solidFill>
                 <a:latin typeface="IBM Plex Mono"/>
               </a:rPr>
-              <a:t># What is waiting, and what already ran?</a:t>
+              <a:t># Schema first: creates and alters, never drops</a:t>
             </a:r>
           </a:p>
           <a:p>
@@ -55108,7 +55108,7 @@
                 </a:solidFill>
                 <a:latin typeface="IBM Plex Mono"/>
               </a:rPr>
-              <a:t>./vendor/bin/typo3 upgrade:list</a:t>
+              <a:t>./vendor/bin/typo3 extension:setup</a:t>
             </a:r>
           </a:p>
           <a:p>
@@ -55127,7 +55127,7 @@
                 </a:solidFill>
                 <a:latin typeface="IBM Plex Mono"/>
               </a:rPr>
-              <a:t>./vendor/bin/typo3 upgrade:list --all</a:t>
+              <a:t>./vendor/bin/typo3 cache:flush</a:t>
             </a:r>
           </a:p>
           <a:p>
@@ -55165,7 +55165,7 @@
                 </a:solidFill>
                 <a:latin typeface="IBM Plex Mono"/>
               </a:rPr>
-              <a:t># Run one, or run them all - scriptable, repeatable, reviewable</a:t>
+              <a:t># What is waiting, and what already ran?</a:t>
             </a:r>
           </a:p>
           <a:p>
@@ -55184,7 +55184,7 @@
                 </a:solidFill>
                 <a:latin typeface="IBM Plex Mono"/>
               </a:rPr>
-              <a:t>./vendor/bin/typo3 upgrade:run pagesRecyclerDoktypeMigration</a:t>
+              <a:t>./vendor/bin/typo3 upgrade:list</a:t>
             </a:r>
           </a:p>
           <a:p>
@@ -55203,7 +55203,7 @@
                 </a:solidFill>
                 <a:latin typeface="IBM Plex Mono"/>
               </a:rPr>
-              <a:t>./vendor/bin/typo3 upgrade:run</a:t>
+              <a:t>./vendor/bin/typo3 upgrade:list --all</a:t>
             </a:r>
           </a:p>
           <a:p>
@@ -55241,7 +55241,7 @@
                 </a:solidFill>
                 <a:latin typeface="IBM Plex Mono"/>
               </a:rPr>
-              <a:t># Schema and extension state</a:t>
+              <a:t># Run one, or run them all - scriptable, repeatable, reviewable</a:t>
             </a:r>
           </a:p>
           <a:p>
@@ -55260,7 +55260,7 @@
                 </a:solidFill>
                 <a:latin typeface="IBM Plex Mono"/>
               </a:rPr>
-              <a:t>./vendor/bin/typo3 extension:setup</a:t>
+              <a:t>./vendor/bin/typo3 upgrade:run pagesRecyclerDoktypeMigration</a:t>
             </a:r>
           </a:p>
           <a:p>
@@ -55279,26 +55279,7 @@
                 </a:solidFill>
                 <a:latin typeface="IBM Plex Mono"/>
               </a:rPr>
-              <a:t>./vendor/bin/typo3 database:updateschema</a:t>
-            </a:r>
-          </a:p>
-          <a:p>
-            <a:pPr algn="l">
-              <a:lnSpc>
-                <a:spcPct val="106000"/>
-              </a:lnSpc>
-              <a:spcBef>
-                <a:spcPts val="0"/>
-              </a:spcBef>
-            </a:pPr>
-            <a:r>
-              <a:rPr sz="950" b="0" i="0">
-                <a:solidFill>
-                  <a:srgbClr val="C9D6E2"/>
-                </a:solidFill>
-                <a:latin typeface="IBM Plex Mono"/>
-              </a:rPr>
-              <a:t>./vendor/bin/typo3 cache:flush</a:t>
+              <a:t>./vendor/bin/typo3 upgrade:run</a:t>
             </a:r>
           </a:p>
         </p:txBody>
@@ -55311,7 +55292,7 @@
         </p:nvSpPr>
         <p:spPr>
           <a:xfrm>
-            <a:off x="566928" y="4297680"/>
+            <a:off x="566928" y="4142232"/>
             <a:ext cx="11057839" cy="914400"/>
           </a:xfrm>
           <a:prstGeom prst="rect">
@@ -55375,6 +55356,34 @@
                 <a:latin typeface="Barlow"/>
               </a:rPr>
               <a:t>That is how the production run stops being the first run.</a:t>
+            </a:r>
+          </a:p>
+          <a:p>
+            <a:pPr algn="l">
+              <a:lnSpc>
+                <a:spcPct val="112000"/>
+              </a:lnSpc>
+              <a:spcBef>
+                <a:spcPts val="700"/>
+              </a:spcBef>
+            </a:pPr>
+            <a:r>
+              <a:rPr sz="1250" b="0" i="0">
+                <a:solidFill>
+                  <a:srgbClr val="FF8700"/>
+                </a:solidFill>
+                <a:latin typeface="Barlow"/>
+              </a:rPr>
+              <a:t>◆  </a:t>
+            </a:r>
+            <a:r>
+              <a:rPr sz="1250" b="0" i="0">
+                <a:solidFill>
+                  <a:srgbClr val="EAF0F6"/>
+                </a:solidFill>
+                <a:latin typeface="Barlow"/>
+              </a:rPr>
+              <a:t>database:updateschema is TYPO3 Console, not core. Drops and renames: Analyze Database Structure.</a:t>
             </a:r>
           </a:p>
         </p:txBody>

</xml_diff>